<commit_message>
Seguridad: administrador propio, registro con aprobación, contraseñas seguras y PostgreSQL en la nube
- Login con correo o nombre de usuario
- Registro público: la cuenta queda pendiente hasta que un administrador la aprueba y asigna el rol
- Política de contraseñas seguras (backend y frontend), BCrypt costo 12
- Bloqueo de 15 min tras 5 intentos fallidos y límite de 20 intentos/min por IP
- Administrador dueño creado desde variables secretas (ADMIN_*)
- En la nube: usuarios demo desactivados, consola H2 apagada, token de recuperación oculto
- render.yaml con base PostgreSQL gratuita para conservar las cuentas
- Documentación, diagramas y pruebas actualizados (89 backend, 9 frontend)

Co-Authored-By: Claude Opus 5.5 <noreply@anthropic.com>
Claude-Session: https://claude.ai/code/session_01EGkMhwJUMh3ySyVKjuwtct
</commit_message>
<xml_diff>
--- a/docs/presentacion/DroneMission-Pro-Vistas.pptx
+++ b/docs/presentacion/DroneMission-Pro-Vistas.pptx
@@ -10428,8 +10428,8 @@
         </p:blipFill>
         <p:spPr>
           <a:xfrm>
-            <a:off x="4745108" y="1330000"/>
-            <a:ext cx="2693044" cy="5300000"/>
+            <a:off x="4860480" y="1330000"/>
+            <a:ext cx="2462300" cy="5300000"/>
           </a:xfrm>
           <a:prstGeom prst="rect">
             <a:avLst/>

</xml_diff>